<commit_message>
Modélisation recentrée prévision (ETS/Holt-Winters) + reformulation neutre + analyse visuelle des images
- Ajout du lissage exponentiel ETS/Holt-Winters : meilleur de la famille statistique classique (devant SARIMA/SARIMAX)
- Recit recentre sur la prevision : modele retenu = regression dynamique de serie temporelle (retards+saisonnalite), defendu en langage TS
- Reformulation neutre de l audit qualite (retrait du cadrage piege/correcteur)
- Onglet Analyse visuelle : exploitation critique des images fournies (validation croisee) + limites documentees
- Renommage Regression lineaire -> Regression dynamique partout

Co-Authored-By: Claude Opus 4.8 <noreply@anthropic.com>
</commit_message>
<xml_diff>
--- a/rendu_final/05_Rapport_Management_Projet.pptx
+++ b/rendu_final/05_Rapport_Management_Projet.pptx
@@ -203,28 +203,31 @@
           </c:dLbls>
           <c:cat>
             <c:strRef>
-              <c:f>Sheet1!$A$2:$A$8</c:f>
+              <c:f>Sheet1!$A$2:$A$9</c:f>
               <c:strCache>
-                <c:ptCount val="7"/>
+                <c:ptCount val="8"/>
                 <c:pt idx="0">
-                  <c:v>Rég. linéaire</c:v>
+                  <c:v>Rég. dyn.</c:v>
                 </c:pt>
                 <c:pt idx="1">
                   <c:v>Métier</c:v>
                 </c:pt>
                 <c:pt idx="2">
+                  <c:v>ETS</c:v>
+                </c:pt>
+                <c:pt idx="3">
                   <c:v>SARIMAX</c:v>
                 </c:pt>
-                <c:pt idx="3">
+                <c:pt idx="4">
                   <c:v>Random Forest</c:v>
                 </c:pt>
-                <c:pt idx="4">
+                <c:pt idx="5">
                   <c:v>SARIMA</c:v>
                 </c:pt>
-                <c:pt idx="5">
+                <c:pt idx="6">
                   <c:v>Sais. naïf</c:v>
                 </c:pt>
-                <c:pt idx="6">
+                <c:pt idx="7">
                   <c:v>Naïve</c:v>
                 </c:pt>
               </c:strCache>
@@ -232,10 +235,10 @@
           </c:cat>
           <c:val>
             <c:numRef>
-              <c:f>Sheet1!$B$2:$B$8</c:f>
+              <c:f>Sheet1!$B$2:$B$9</c:f>
               <c:numCache>
                 <c:formatCode>General</c:formatCode>
-                <c:ptCount val="7"/>
+                <c:ptCount val="8"/>
                 <c:pt idx="0">
                   <c:v>5.61</c:v>
                 </c:pt>
@@ -243,18 +246,21 @@
                   <c:v>7.75</c:v>
                 </c:pt>
                 <c:pt idx="2">
+                  <c:v>7.77</c:v>
+                </c:pt>
+                <c:pt idx="3">
                   <c:v>8.24</c:v>
                 </c:pt>
-                <c:pt idx="3">
+                <c:pt idx="4">
                   <c:v>9.44</c:v>
-                </c:pt>
-                <c:pt idx="4">
-                  <c:v>9.61</c:v>
                 </c:pt>
                 <c:pt idx="5">
                   <c:v>9.61</c:v>
                 </c:pt>
                 <c:pt idx="6">
+                  <c:v>9.61</c:v>
+                </c:pt>
+                <c:pt idx="7">
                   <c:v>11.31</c:v>
                 </c:pt>
               </c:numCache>
@@ -2474,7 +2480,7 @@
                 <a:ea typeface="Arial" pitchFamily="34" charset="-122"/>
                 <a:cs typeface="Arial" pitchFamily="34" charset="-120"/>
               </a:rPr>
-              <a:t>Deux questions de natures différentes — les confondre est le premier piège</a:t>
+              <a:t>Deux questions de natures différentes — à ne surtout pas confondre</a:t>
             </a:r>
             <a:endParaRPr lang="en-US" sz="1300" dirty="0"/>
           </a:p>
@@ -2508,6 +2514,10 @@
             </a:outerShdw>
           </a:effectLst>
         </p:spPr>
+        <p:txBody>
+          <a:bodyPr/>
+          <a:p/>
+        </p:txBody>
       </p:sp>
       <p:sp>
         <p:nvSpPr>
@@ -2528,6 +2538,10 @@
           </a:solidFill>
           <a:ln/>
         </p:spPr>
+        <p:txBody>
+          <a:bodyPr/>
+          <a:p/>
+        </p:txBody>
       </p:sp>
       <p:sp>
         <p:nvSpPr>
@@ -2674,6 +2688,10 @@
             </a:outerShdw>
           </a:effectLst>
         </p:spPr>
+        <p:txBody>
+          <a:bodyPr/>
+          <a:p/>
+        </p:txBody>
       </p:sp>
       <p:sp>
         <p:nvSpPr>
@@ -2694,6 +2712,10 @@
           </a:solidFill>
           <a:ln/>
         </p:spPr>
+        <p:txBody>
+          <a:bodyPr/>
+          <a:p/>
+        </p:txBody>
       </p:sp>
       <p:sp>
         <p:nvSpPr>
@@ -2833,6 +2855,10 @@
           </a:solidFill>
           <a:ln/>
         </p:spPr>
+        <p:txBody>
+          <a:bodyPr/>
+          <a:p/>
+        </p:txBody>
       </p:sp>
       <p:sp>
         <p:nvSpPr>
@@ -3068,6 +3094,10 @@
             </a:outerShdw>
           </a:effectLst>
         </p:spPr>
+        <p:txBody>
+          <a:bodyPr/>
+          <a:p/>
+        </p:txBody>
       </p:sp>
       <p:sp>
         <p:nvSpPr>
@@ -3175,6 +3205,10 @@
             </a:outerShdw>
           </a:effectLst>
         </p:spPr>
+        <p:txBody>
+          <a:bodyPr/>
+          <a:p/>
+        </p:txBody>
       </p:sp>
       <p:sp>
         <p:nvSpPr>
@@ -3282,6 +3316,10 @@
             </a:outerShdw>
           </a:effectLst>
         </p:spPr>
+        <p:txBody>
+          <a:bodyPr/>
+          <a:p/>
+        </p:txBody>
       </p:sp>
       <p:sp>
         <p:nvSpPr>
@@ -3389,6 +3427,10 @@
             </a:outerShdw>
           </a:effectLst>
         </p:spPr>
+        <p:txBody>
+          <a:bodyPr/>
+          <a:p/>
+        </p:txBody>
       </p:sp>
       <p:sp>
         <p:nvSpPr>
@@ -3489,6 +3531,10 @@
           </a:solidFill>
           <a:ln/>
         </p:spPr>
+        <p:txBody>
+          <a:bodyPr/>
+          <a:p/>
+        </p:txBody>
       </p:sp>
       <p:sp>
         <p:nvSpPr>
@@ -3569,7 +3615,7 @@
                 <a:ea typeface="Arial" pitchFamily="34" charset="-122"/>
                 <a:cs typeface="Arial" pitchFamily="34" charset="-120"/>
               </a:rPr>
-              <a:t>05_cible_recommandation.csv : aucune donnée, un message de l'examinateur (« décider, pas copier ») → pas de variable cible de reco.</a:t>
+              <a:t>05_cible_recommandation.csv : aucune donnée, un fichier en texte libre, sans données structurées → pas de variable cible de reco.</a:t>
             </a:r>
             <a:endParaRPr lang="en-US" sz="1200" dirty="0"/>
           </a:p>
@@ -4215,7 +4261,7 @@
                 <a:ea typeface="Arial" pitchFamily="34" charset="-122"/>
                 <a:cs typeface="Arial" pitchFamily="34" charset="-120"/>
               </a:rPr>
-              <a:t>régression linéaire (saisonnalité + retards + effet pays), interprétable — préférée à SARIMA/SARIMAX (séries courtes), validée par backtest.</a:t>
+              <a:t>régression dynamique (retards lag1/lag12 + saisonnalité + effet pays), interprétable — préférée à SARIMA/SARIMAX (séries courtes), validée par backtest.</a:t>
             </a:r>
             <a:endParaRPr lang="en-US" sz="1350" dirty="0"/>
           </a:p>
@@ -4441,7 +4487,7 @@
                 <a:ea typeface="Arial" pitchFamily="34" charset="-122"/>
                 <a:cs typeface="Arial" pitchFamily="34" charset="-120"/>
               </a:rPr>
-              <a:t>Cible : demand_index · 2 familles (SARIMA/SARIMAX vs ML) · multi-pas · Time Series CV (12 plis) + split train/validation/test</a:t>
+              <a:t>Cible : demand_index · plusieurs approches de prévision (ETS, SARIMA, SARIMAX, rég. dynamique) · multi-pas · Time Series CV + 3-way</a:t>
             </a:r>
             <a:endParaRPr lang="en-US" sz="1300" dirty="0"/>
           </a:p>
@@ -4584,7 +4630,7 @@
                 </a:solidFill>
                 <a:latin typeface="Arial"/>
               </a:rPr>
-              <a:t>Deux familles comparées en prévision multi-pas.</a:t>
+              <a:t>Plusieurs approches de prévision comparées (même domaine temporel).</a:t>
             </a:r>
             <a:endParaRPr lang="en-US" sz="1250" dirty="0"/>
           </a:p>
@@ -4601,7 +4647,7 @@
                 </a:solidFill>
                 <a:latin typeface="Arial"/>
               </a:rPr>
-              <a:t>Statistique native : SARIMAX (8,2) bat SARIMA (9,6) — la saisonnalité déterministe stabilise les séries courtes.</a:t>
+              <a:t>Famille statistique : ETS/Holt-Winters mène, devant SARIMA et SARIMAX.</a:t>
             </a:r>
           </a:p>
           <a:p>
@@ -4617,7 +4663,7 @@
                 </a:solidFill>
                 <a:latin typeface="Arial"/>
               </a:rPr>
-              <a:t>ML : la régression linéaire globale gagne (MAE 5,6 ; 5/8 pays).</a:t>
+              <a:t>Modèle retenu : régression dynamique de série temporelle (MAE 5.6, 5/8 pays).</a:t>
             </a:r>
           </a:p>
           <a:p>
@@ -4633,7 +4679,7 @@
                 </a:solidFill>
                 <a:latin typeface="Arial"/>
               </a:rPr>
-              <a:t>Sur ~30 pts/pays, mutualiser entre pays bat un SARIMA univariate : la complexité statistique ne se justifie pas ici.</a:t>
+              <a:t>Elle mutualise les 8 séries — ce qu un modèle univarié ne peut pas sur ~30 points/pays. Random Forest nettement battu.</a:t>
             </a:r>
           </a:p>
         </p:txBody>
@@ -4776,6 +4822,10 @@
             </a:outerShdw>
           </a:effectLst>
         </p:spPr>
+        <p:txBody>
+          <a:bodyPr/>
+          <a:p/>
+        </p:txBody>
       </p:sp>
       <p:sp>
         <p:nvSpPr>
@@ -4796,6 +4846,10 @@
           </a:solidFill>
           <a:ln/>
         </p:spPr>
+        <p:txBody>
+          <a:bodyPr/>
+          <a:p/>
+        </p:txBody>
       </p:sp>
       <p:sp>
         <p:nvSpPr>
@@ -4906,6 +4960,10 @@
             </a:outerShdw>
           </a:effectLst>
         </p:spPr>
+        <p:txBody>
+          <a:bodyPr/>
+          <a:p/>
+        </p:txBody>
       </p:sp>
       <p:sp>
         <p:nvSpPr>
@@ -4926,6 +4984,10 @@
           </a:solidFill>
           <a:ln/>
         </p:spPr>
+        <p:txBody>
+          <a:bodyPr/>
+          <a:p/>
+        </p:txBody>
       </p:sp>
       <p:sp>
         <p:nvSpPr>
@@ -5002,7 +5064,7 @@
                 <a:ea typeface="Arial" pitchFamily="34" charset="-122"/>
                 <a:cs typeface="Arial" pitchFamily="34" charset="-120"/>
               </a:rPr>
-              <a:t>Privilégier l'interprétabilité et la robustesse à la complexité. Régression linéaire &gt; Random Forest ici.</a:t>
+              <a:t>Privilégier l'interprétabilité et la robustesse à la complexité. Régression dynamique &gt; Random Forest ici.</a:t>
             </a:r>
             <a:endParaRPr lang="en-US" sz="1200" dirty="0"/>
           </a:p>
@@ -5036,6 +5098,10 @@
             </a:outerShdw>
           </a:effectLst>
         </p:spPr>
+        <p:txBody>
+          <a:bodyPr/>
+          <a:p/>
+        </p:txBody>
       </p:sp>
       <p:sp>
         <p:nvSpPr>
@@ -5056,6 +5122,10 @@
           </a:solidFill>
           <a:ln/>
         </p:spPr>
+        <p:txBody>
+          <a:bodyPr/>
+          <a:p/>
+        </p:txBody>
       </p:sp>
       <p:sp>
         <p:nvSpPr>
@@ -5596,6 +5666,10 @@
             </a:outerShdw>
           </a:effectLst>
         </p:spPr>
+        <p:txBody>
+          <a:bodyPr/>
+          <a:p/>
+        </p:txBody>
       </p:sp>
       <p:sp>
         <p:nvSpPr>
@@ -5706,6 +5780,10 @@
             </a:outerShdw>
           </a:effectLst>
         </p:spPr>
+        <p:txBody>
+          <a:bodyPr/>
+          <a:p/>
+        </p:txBody>
       </p:sp>
       <p:sp>
         <p:nvSpPr>
@@ -5816,6 +5894,10 @@
             </a:outerShdw>
           </a:effectLst>
         </p:spPr>
+        <p:txBody>
+          <a:bodyPr/>
+          <a:p/>
+        </p:txBody>
       </p:sp>
       <p:sp>
         <p:nvSpPr>
@@ -5926,6 +6008,10 @@
             </a:outerShdw>
           </a:effectLst>
         </p:spPr>
+        <p:txBody>
+          <a:bodyPr/>
+          <a:p/>
+        </p:txBody>
       </p:sp>
       <p:sp>
         <p:nvSpPr>
@@ -6144,7 +6230,7 @@
                 <a:ea typeface="Arial" pitchFamily="34" charset="-122"/>
                 <a:cs typeface="Arial" pitchFamily="34" charset="-120"/>
               </a:rPr>
-              <a:t>Décider, pas copier : la recommandation est un score multicritère dont les pondérations sont un arbitrage à assumer devant le jury.</a:t>
+              <a:t>la recommandation est un score multicritère dont les pondérations sont un arbitrage à assumer devant le jury.</a:t>
             </a:r>
             <a:endParaRPr lang="en-US" sz="1600" dirty="0"/>
           </a:p>

</xml_diff>